<commit_message>
Correct TikTok profile links throughout the site and downloads
</commit_message>
<xml_diff>
--- a/docs/mediakit/downloads/nanobots-mediakit.pptx
+++ b/docs/mediakit/downloads/nanobots-mediakit.pptx
@@ -31042,7 +31042,7 @@
       </p:sp>
       <p:sp>
         <p:nvSpPr>
-          <p:cNvPr id="13" name="@nanobots_mult1">
+          <p:cNvPr id="13" name="@nanobots_mult">
             <a:extLst xmlns:a="http://schemas.openxmlformats.org/drawingml/2006/main">
               <a:ext uri="{FF2B5EF4-FFF2-40B4-BE49-F238E27FC236}">
                 <a16:creationId xmlns:a16="http://schemas.microsoft.com/office/drawing/2014/main" id="{5150177F-3C84-4ED1-8D02-8A6B77ECF504}"/>
@@ -31204,7 +31204,7 @@
                 <a:cs typeface="Geologica"/>
                 <a:hlinkClick xmlns:r="http://schemas.openxmlformats.org/officeDocument/2006/relationships" r:id="Rfae9ecf0aa2244ed"/>
               </a:rPr>
-              <a:t>@nanobots_mult1</a:t>
+              <a:t>@nanobots_mult</a:t>
             </a:r>
           </a:p>
         </p:txBody>

</xml_diff>